<commit_message>
update: mise a jour du support Steam_presentation.pptx
</commit_message>
<xml_diff>
--- a/Bloc_2_Analyse_Exploratoire/Steam/Steam_presentation.pptx
+++ b/Bloc_2_Analyse_Exploratoire/Steam/Steam_presentation.pptx
@@ -11243,7 +11243,7 @@
         <p:spPr>
           <a:xfrm>
             <a:off x="1828800" y="1463040"/>
-            <a:ext cx="8534095" cy="365760"/>
+            <a:ext cx="8534100" cy="461700"/>
           </a:xfrm>
           <a:prstGeom prst="rect">
             <a:avLst/>
@@ -11269,7 +11269,7 @@
               <a:buNone/>
             </a:pPr>
             <a:r>
-              <a:rPr b="1" i="0" lang="en-US" sz="1200" u="none" cap="none" strike="noStrike">
+              <a:rPr b="1" i="0" lang="en-US" sz="2400" u="none" cap="none" strike="noStrike">
                 <a:solidFill>
                   <a:srgbClr val="38BDF8"/>
                 </a:solidFill>
@@ -11280,7 +11280,7 @@
               </a:rPr>
               <a:t>BLOC 2 — ANALYSE EXPLORATOIRE DE DONNÉES BIG DATA</a:t>
             </a:r>
-            <a:endParaRPr/>
+            <a:endParaRPr sz="2600"/>
           </a:p>
         </p:txBody>
       </p:sp>
@@ -11433,7 +11433,7 @@
         <p:spPr>
           <a:xfrm>
             <a:off x="2011680" y="3520440"/>
-            <a:ext cx="2286000" cy="1005840"/>
+            <a:ext cx="2286000" cy="1015800"/>
           </a:xfrm>
           <a:prstGeom prst="rect">
             <a:avLst/>
@@ -11459,7 +11459,7 @@
               <a:buNone/>
             </a:pPr>
             <a:r>
-              <a:rPr b="1" i="0" lang="en-US" sz="2000" u="none" cap="none" strike="noStrike">
+              <a:rPr b="1" i="0" lang="en-US" sz="2300" u="none" cap="none" strike="noStrike">
                 <a:solidFill>
                   <a:srgbClr val="38BDF8"/>
                 </a:solidFill>
@@ -11470,7 +11470,7 @@
               </a:rPr>
               <a:t>55 691</a:t>
             </a:r>
-            <a:endParaRPr/>
+            <a:endParaRPr sz="1700"/>
           </a:p>
           <a:p>
             <a:pPr indent="0" lvl="0" marL="0" marR="0" rtl="0" algn="l">
@@ -11483,7 +11483,7 @@
               <a:buNone/>
             </a:pPr>
             <a:r>
-              <a:rPr b="1" i="0" lang="en-US" sz="1000" u="none" cap="none" strike="noStrike">
+              <a:rPr b="1" i="0" lang="en-US" sz="1300" u="none" cap="none" strike="noStrike">
                 <a:solidFill>
                   <a:srgbClr val="F8FAFC"/>
                 </a:solidFill>
@@ -11494,7 +11494,7 @@
               </a:rPr>
               <a:t>JEUX ANALYSÉS</a:t>
             </a:r>
-            <a:endParaRPr/>
+            <a:endParaRPr sz="1700"/>
           </a:p>
           <a:p>
             <a:pPr indent="0" lvl="0" marL="0" marR="0" rtl="0" algn="l">
@@ -11507,7 +11507,7 @@
               <a:buNone/>
             </a:pPr>
             <a:r>
-              <a:rPr b="0" i="0" lang="en-US" sz="900" u="none" cap="none" strike="noStrike">
+              <a:rPr b="0" i="0" lang="en-US" sz="1200" u="none" cap="none" strike="noStrike">
                 <a:solidFill>
                   <a:srgbClr val="94A3B8"/>
                 </a:solidFill>
@@ -11518,7 +11518,7 @@
               </a:rPr>
               <a:t>Dump JSON multi-lignes AWS S3</a:t>
             </a:r>
-            <a:endParaRPr/>
+            <a:endParaRPr sz="1700"/>
           </a:p>
         </p:txBody>
       </p:sp>
@@ -11597,7 +11597,7 @@
         <p:spPr>
           <a:xfrm>
             <a:off x="4937760" y="3520440"/>
-            <a:ext cx="2286000" cy="1005840"/>
+            <a:ext cx="2286000" cy="877200"/>
           </a:xfrm>
           <a:prstGeom prst="rect">
             <a:avLst/>
@@ -11623,7 +11623,7 @@
               <a:buNone/>
             </a:pPr>
             <a:r>
-              <a:rPr b="1" i="0" lang="en-US" sz="2000" u="none" cap="none" strike="noStrike">
+              <a:rPr b="1" i="0" lang="en-US" sz="2400" u="none" cap="none" strike="noStrike">
                 <a:solidFill>
                   <a:srgbClr val="10B981"/>
                 </a:solidFill>
@@ -11634,7 +11634,7 @@
               </a:rPr>
               <a:t>1.05 Md€</a:t>
             </a:r>
-            <a:endParaRPr/>
+            <a:endParaRPr sz="1800"/>
           </a:p>
           <a:p>
             <a:pPr indent="0" lvl="0" marL="0" marR="0" rtl="0" algn="l">
@@ -11647,7 +11647,7 @@
               <a:buNone/>
             </a:pPr>
             <a:r>
-              <a:rPr b="1" i="0" lang="en-US" sz="1000" u="none" cap="none" strike="noStrike">
+              <a:rPr b="1" i="0" lang="en-US" u="none" cap="none" strike="noStrike">
                 <a:solidFill>
                   <a:srgbClr val="F8FAFC"/>
                 </a:solidFill>
@@ -11658,7 +11658,7 @@
               </a:rPr>
               <a:t>PROXY REVENUS ACTION</a:t>
             </a:r>
-            <a:endParaRPr/>
+            <a:endParaRPr sz="1800"/>
           </a:p>
           <a:p>
             <a:pPr indent="0" lvl="0" marL="0" marR="0" rtl="0" algn="l">
@@ -11671,7 +11671,7 @@
               <a:buNone/>
             </a:pPr>
             <a:r>
-              <a:rPr b="0" i="0" lang="en-US" sz="900" u="none" cap="none" strike="noStrike">
+              <a:rPr b="0" i="0" lang="en-US" sz="1300" u="none" cap="none" strike="noStrike">
                 <a:solidFill>
                   <a:srgbClr val="94A3B8"/>
                 </a:solidFill>
@@ -11682,7 +11682,7 @@
               </a:rPr>
               <a:t>Genre dominant de l'industrie</a:t>
             </a:r>
-            <a:endParaRPr/>
+            <a:endParaRPr sz="1800"/>
           </a:p>
         </p:txBody>
       </p:sp>
@@ -11761,7 +11761,7 @@
         <p:spPr>
           <a:xfrm>
             <a:off x="7863840" y="3520440"/>
-            <a:ext cx="2286000" cy="1005840"/>
+            <a:ext cx="2286000" cy="877200"/>
           </a:xfrm>
           <a:prstGeom prst="rect">
             <a:avLst/>
@@ -11787,7 +11787,7 @@
               <a:buNone/>
             </a:pPr>
             <a:r>
-              <a:rPr b="1" i="0" lang="en-US" sz="2000" u="none" cap="none" strike="noStrike">
+              <a:rPr b="1" i="0" lang="en-US" sz="2400" u="none" cap="none" strike="noStrike">
                 <a:solidFill>
                   <a:srgbClr val="F59E0B"/>
                 </a:solidFill>
@@ -11798,7 +11798,7 @@
               </a:rPr>
               <a:t>14.0% / 86.0%</a:t>
             </a:r>
-            <a:endParaRPr/>
+            <a:endParaRPr sz="1800"/>
           </a:p>
           <a:p>
             <a:pPr indent="0" lvl="0" marL="0" marR="0" rtl="0" algn="l">
@@ -11811,7 +11811,7 @@
               <a:buNone/>
             </a:pPr>
             <a:r>
-              <a:rPr b="1" i="0" lang="en-US" sz="1000" u="none" cap="none" strike="noStrike">
+              <a:rPr b="1" i="0" lang="en-US" u="none" cap="none" strike="noStrike">
                 <a:solidFill>
                   <a:srgbClr val="F8FAFC"/>
                 </a:solidFill>
@@ -11822,7 +11822,7 @@
               </a:rPr>
               <a:t>GRATUIT VS PAYANT</a:t>
             </a:r>
-            <a:endParaRPr/>
+            <a:endParaRPr sz="1800"/>
           </a:p>
           <a:p>
             <a:pPr indent="0" lvl="0" marL="0" marR="0" rtl="0" algn="l">
@@ -11835,7 +11835,7 @@
               <a:buNone/>
             </a:pPr>
             <a:r>
-              <a:rPr b="0" i="0" lang="en-US" sz="900" u="none" cap="none" strike="noStrike">
+              <a:rPr b="0" i="0" lang="en-US" sz="1300" u="none" cap="none" strike="noStrike">
                 <a:solidFill>
                   <a:srgbClr val="94A3B8"/>
                 </a:solidFill>
@@ -11846,7 +11846,7 @@
               </a:rPr>
               <a:t>Monétisation &amp; élasticité prix</a:t>
             </a:r>
-            <a:endParaRPr/>
+            <a:endParaRPr sz="1800"/>
           </a:p>
         </p:txBody>
       </p:sp>
@@ -11859,7 +11859,7 @@
         <p:spPr>
           <a:xfrm>
             <a:off x="1828800" y="4937760"/>
-            <a:ext cx="8534095" cy="457200"/>
+            <a:ext cx="8534100" cy="261600"/>
           </a:xfrm>
           <a:prstGeom prst="rect">
             <a:avLst/>
@@ -11894,7 +11894,7 @@
                 <a:cs typeface="Quattrocento Sans"/>
                 <a:sym typeface="Quattrocento Sans"/>
               </a:rPr>
-              <a:t>Candidat : Christopher GILLERON   |   Commanditaire : Ubisoft   |   Certification CDSD (Niveau 7)   |   Soutenance 5 min (8 slides)</a:t>
+              <a:t>Candidat : Christopher GILLERON   </a:t>
             </a:r>
             <a:endParaRPr/>
           </a:p>
@@ -11971,7 +11971,7 @@
             <a:r>
               <a:t/>
             </a:r>
-            <a:endParaRPr b="0" i="0" sz="1800" u="none" cap="none" strike="noStrike">
+            <a:endParaRPr b="0" i="0" sz="2200" u="none" cap="none" strike="noStrike">
               <a:solidFill>
                 <a:schemeClr val="dk1"/>
               </a:solidFill>
@@ -11992,7 +11992,7 @@
         <p:spPr>
           <a:xfrm>
             <a:off x="731520" y="365760"/>
-            <a:ext cx="7315200" cy="320040"/>
+            <a:ext cx="7315200" cy="307800"/>
           </a:xfrm>
           <a:prstGeom prst="rect">
             <a:avLst/>
@@ -12018,7 +12018,7 @@
               <a:buNone/>
             </a:pPr>
             <a:r>
-              <a:rPr b="1" i="0" lang="en-US" sz="1100" u="none" cap="none" strike="noStrike">
+              <a:rPr b="1" i="0" lang="en-US" sz="2000" u="none" cap="none" strike="noStrike">
                 <a:solidFill>
                   <a:srgbClr val="38BDF8"/>
                 </a:solidFill>
@@ -12029,7 +12029,7 @@
               </a:rPr>
               <a:t>ÉTAPE 01 | CADRAGE &amp; PIPELINE TECHNIQUE</a:t>
             </a:r>
-            <a:endParaRPr/>
+            <a:endParaRPr sz="2300"/>
           </a:p>
         </p:txBody>
       </p:sp>
@@ -12042,7 +12042,7 @@
         <p:spPr>
           <a:xfrm>
             <a:off x="731520" y="685800"/>
-            <a:ext cx="9601200" cy="502920"/>
+            <a:ext cx="9601200" cy="338700"/>
           </a:xfrm>
           <a:prstGeom prst="rect">
             <a:avLst/>
@@ -12068,7 +12068,7 @@
               <a:buNone/>
             </a:pPr>
             <a:r>
-              <a:rPr b="1" i="0" lang="en-US" sz="1800" u="none" cap="none" strike="noStrike">
+              <a:rPr b="1" i="0" lang="en-US" sz="2200" u="none" cap="none" strike="noStrike">
                 <a:solidFill>
                   <a:srgbClr val="F8FAFC"/>
                 </a:solidFill>
@@ -12079,7 +12079,7 @@
               </a:rPr>
               <a:t>Contexte Stratégique Ubisoft &amp; Architecture Big Data PySpark</a:t>
             </a:r>
-            <a:endParaRPr/>
+            <a:endParaRPr sz="1800"/>
           </a:p>
         </p:txBody>
       </p:sp>
@@ -12092,7 +12092,7 @@
         <p:spPr>
           <a:xfrm>
             <a:off x="10362895" y="411480"/>
-            <a:ext cx="1097280" cy="365760"/>
+            <a:ext cx="1097400" cy="246300"/>
           </a:xfrm>
           <a:prstGeom prst="rect">
             <a:avLst/>
@@ -12118,7 +12118,7 @@
               <a:buNone/>
             </a:pPr>
             <a:r>
-              <a:rPr b="1" i="0" lang="en-US" sz="1200" u="none" cap="none" strike="noStrike">
+              <a:rPr b="1" i="0" lang="en-US" sz="1600" u="none" cap="none" strike="noStrike">
                 <a:solidFill>
                   <a:srgbClr val="94A3B8"/>
                 </a:solidFill>
@@ -12129,7 +12129,7 @@
               </a:rPr>
               <a:t>2 / 8</a:t>
             </a:r>
-            <a:endParaRPr/>
+            <a:endParaRPr sz="1800"/>
           </a:p>
         </p:txBody>
       </p:sp>
@@ -12142,7 +12142,7 @@
         <p:spPr>
           <a:xfrm>
             <a:off x="731520" y="6400800"/>
-            <a:ext cx="10728655" cy="274320"/>
+            <a:ext cx="10728600" cy="277200"/>
           </a:xfrm>
           <a:prstGeom prst="rect">
             <a:avLst/>
@@ -12168,18 +12168,9 @@
               <a:buNone/>
             </a:pPr>
             <a:r>
-              <a:rPr b="0" i="0" lang="en-US" sz="950" u="none" cap="none" strike="noStrike">
-                <a:solidFill>
-                  <a:srgbClr val="94A3B8"/>
-                </a:solidFill>
-                <a:latin typeface="Quattrocento Sans"/>
-                <a:ea typeface="Quattrocento Sans"/>
-                <a:cs typeface="Quattrocento Sans"/>
-                <a:sym typeface="Quattrocento Sans"/>
-              </a:rPr>
-              <a:t>Christopher GILLERON  |  Steam Video Games Analysis (PySpark / Databricks)  |  Certification CDSD Bloc 2  |  Temps alloué : 5 min</a:t>
-            </a:r>
-            <a:endParaRPr/>
+              <a:t/>
+            </a:r>
+            <a:endParaRPr sz="1800"/>
           </a:p>
         </p:txBody>
       </p:sp>
@@ -12237,7 +12228,7 @@
             <a:r>
               <a:t/>
             </a:r>
-            <a:endParaRPr b="0" i="0" sz="1800" u="none" cap="none" strike="noStrike">
+            <a:endParaRPr b="0" i="0" sz="2200" u="none" cap="none" strike="noStrike">
               <a:solidFill>
                 <a:schemeClr val="dk1"/>
               </a:solidFill>
@@ -12258,7 +12249,7 @@
         <p:spPr>
           <a:xfrm>
             <a:off x="914400" y="1554480"/>
-            <a:ext cx="4846320" cy="4480560"/>
+            <a:ext cx="4846200" cy="3745500"/>
           </a:xfrm>
           <a:prstGeom prst="rect">
             <a:avLst/>
@@ -12284,7 +12275,7 @@
               <a:buNone/>
             </a:pPr>
             <a:r>
-              <a:rPr b="1" i="0" lang="en-US" sz="1400" u="none" cap="none" strike="noStrike">
+              <a:rPr b="1" i="0" lang="en-US" sz="1800" u="none" cap="none" strike="noStrike">
                 <a:solidFill>
                   <a:srgbClr val="38BDF8"/>
                 </a:solidFill>
@@ -12295,7 +12286,7 @@
               </a:rPr>
               <a:t>01 | CONTEXTE STRATÉGIQUE UBISOFT</a:t>
             </a:r>
-            <a:endParaRPr/>
+            <a:endParaRPr sz="1800"/>
           </a:p>
           <a:p>
             <a:pPr indent="0" lvl="0" marL="0" marR="0" rtl="0" algn="l">
@@ -12308,7 +12299,7 @@
               <a:buNone/>
             </a:pPr>
             <a:r>
-              <a:rPr b="1" i="0" lang="en-US" sz="1100" u="none" cap="none" strike="noStrike">
+              <a:rPr b="1" i="0" lang="en-US" sz="1500" u="none" cap="none" strike="noStrike">
                 <a:solidFill>
                   <a:srgbClr val="F8FAFC"/>
                 </a:solidFill>
@@ -12319,7 +12310,7 @@
               </a:rPr>
               <a:t>Mandat Ubisoft :</a:t>
             </a:r>
-            <a:endParaRPr/>
+            <a:endParaRPr sz="1800"/>
           </a:p>
           <a:p>
             <a:pPr indent="0" lvl="0" marL="0" marR="0" rtl="0" algn="l">
@@ -12332,7 +12323,7 @@
               <a:buNone/>
             </a:pPr>
             <a:r>
-              <a:rPr b="0" i="0" lang="en-US" sz="1000" u="none" cap="none" strike="noStrike">
+              <a:rPr b="0" i="0" lang="en-US" u="none" cap="none" strike="noStrike">
                 <a:solidFill>
                   <a:srgbClr val="94A3B8"/>
                 </a:solidFill>
@@ -12343,7 +12334,7 @@
               </a:rPr>
               <a:t>Explorer l'intégralité du catalogue Steam pour orienter la conception, le pricing et le positionnement du prochain jeu phare.</a:t>
             </a:r>
-            <a:endParaRPr/>
+            <a:endParaRPr sz="1800"/>
           </a:p>
           <a:p>
             <a:pPr indent="0" lvl="0" marL="0" marR="0" rtl="0" algn="l">
@@ -12356,7 +12347,7 @@
               <a:buNone/>
             </a:pPr>
             <a:r>
-              <a:rPr b="1" i="0" lang="en-US" sz="1100" u="none" cap="none" strike="noStrike">
+              <a:rPr b="1" i="0" lang="en-US" sz="1500" u="none" cap="none" strike="noStrike">
                 <a:solidFill>
                   <a:srgbClr val="F8FAFC"/>
                 </a:solidFill>
@@ -12367,7 +12358,7 @@
               </a:rPr>
               <a:t>Périmètre Données :</a:t>
             </a:r>
-            <a:endParaRPr/>
+            <a:endParaRPr sz="1800"/>
           </a:p>
           <a:p>
             <a:pPr indent="0" lvl="0" marL="0" marR="0" rtl="0" algn="l">
@@ -12380,7 +12371,7 @@
               <a:buNone/>
             </a:pPr>
             <a:r>
-              <a:rPr b="0" i="0" lang="en-US" sz="1000" u="none" cap="none" strike="noStrike">
+              <a:rPr b="0" i="0" lang="en-US" u="none" cap="none" strike="noStrike">
                 <a:solidFill>
                   <a:srgbClr val="94A3B8"/>
                 </a:solidFill>
@@ -12391,7 +12382,7 @@
               </a:rPr>
               <a:t>55 691 jeux vidéo uniques collectés via l'API Steam Web, hébergés sur AWS S3 sous forme de dump JSON semi-structuré.</a:t>
             </a:r>
-            <a:endParaRPr/>
+            <a:endParaRPr sz="1800"/>
           </a:p>
           <a:p>
             <a:pPr indent="0" lvl="0" marL="0" marR="0" rtl="0" algn="l">
@@ -12404,7 +12395,7 @@
               <a:buNone/>
             </a:pPr>
             <a:r>
-              <a:rPr b="1" i="0" lang="en-US" sz="1100" u="none" cap="none" strike="noStrike">
+              <a:rPr b="1" i="0" lang="en-US" sz="1500" u="none" cap="none" strike="noStrike">
                 <a:solidFill>
                   <a:srgbClr val="F8FAFC"/>
                 </a:solidFill>
@@ -12415,7 +12406,7 @@
               </a:rPr>
               <a:t>Enjeux Décisionnels :</a:t>
             </a:r>
-            <a:endParaRPr/>
+            <a:endParaRPr sz="1800"/>
           </a:p>
           <a:p>
             <a:pPr indent="0" lvl="0" marL="0" marR="0" rtl="0" algn="l">
@@ -12428,7 +12419,7 @@
               <a:buNone/>
             </a:pPr>
             <a:r>
-              <a:rPr b="0" i="0" lang="en-US" sz="1000" u="none" cap="none" strike="noStrike">
+              <a:rPr b="0" i="0" lang="en-US" u="none" cap="none" strike="noStrike">
                 <a:solidFill>
                   <a:srgbClr val="94A3B8"/>
                 </a:solidFill>
@@ -12439,7 +12430,7 @@
               </a:rPr>
               <a:t>Identifier les genres les plus lucratifs, mesurer l'impact du Free-to-Play, analyser la concurrence et optimiser le support OS.</a:t>
             </a:r>
-            <a:endParaRPr/>
+            <a:endParaRPr sz="1800"/>
           </a:p>
           <a:p>
             <a:pPr indent="0" lvl="0" marL="0" marR="0" rtl="0" algn="l">
@@ -12452,7 +12443,7 @@
               <a:buNone/>
             </a:pPr>
             <a:r>
-              <a:rPr b="1" i="0" lang="en-US" sz="1100" u="none" cap="none" strike="noStrike">
+              <a:rPr b="1" i="0" lang="en-US" sz="1500" u="none" cap="none" strike="noStrike">
                 <a:solidFill>
                   <a:srgbClr val="F8FAFC"/>
                 </a:solidFill>
@@ -12463,7 +12454,7 @@
               </a:rPr>
               <a:t>Contrainte Volume :</a:t>
             </a:r>
-            <a:endParaRPr/>
+            <a:endParaRPr sz="1800"/>
           </a:p>
           <a:p>
             <a:pPr indent="0" lvl="0" marL="0" marR="0" rtl="0" algn="l">
@@ -12476,7 +12467,7 @@
               <a:buNone/>
             </a:pPr>
             <a:r>
-              <a:rPr b="0" i="0" lang="en-US" sz="1000" u="none" cap="none" strike="noStrike">
+              <a:rPr b="0" i="0" lang="en-US" u="none" cap="none" strike="noStrike">
                 <a:solidFill>
                   <a:srgbClr val="94A3B8"/>
                 </a:solidFill>
@@ -12487,7 +12478,7 @@
               </a:rPr>
               <a:t>Traiter un schéma complexe multi-niveaux sans perte d'information grâce au moteur distribué PySpark sur Databricks.</a:t>
             </a:r>
-            <a:endParaRPr/>
+            <a:endParaRPr sz="1800"/>
           </a:p>
         </p:txBody>
       </p:sp>
@@ -12545,7 +12536,7 @@
             <a:r>
               <a:t/>
             </a:r>
-            <a:endParaRPr b="0" i="0" sz="1800" u="none" cap="none" strike="noStrike">
+            <a:endParaRPr b="0" i="0" sz="2200" u="none" cap="none" strike="noStrike">
               <a:solidFill>
                 <a:schemeClr val="dk1"/>
               </a:solidFill>
@@ -12566,7 +12557,7 @@
         <p:spPr>
           <a:xfrm>
             <a:off x="6400800" y="1554480"/>
-            <a:ext cx="4876495" cy="4480560"/>
+            <a:ext cx="4876500" cy="3807000"/>
           </a:xfrm>
           <a:prstGeom prst="rect">
             <a:avLst/>
@@ -12592,7 +12583,7 @@
               <a:buNone/>
             </a:pPr>
             <a:r>
-              <a:rPr b="1" i="0" lang="en-US" sz="1400" u="none" cap="none" strike="noStrike">
+              <a:rPr b="1" i="0" lang="en-US" sz="1800" u="none" cap="none" strike="noStrike">
                 <a:solidFill>
                   <a:srgbClr val="38BDF8"/>
                 </a:solidFill>
@@ -12603,7 +12594,7 @@
               </a:rPr>
               <a:t>02 | PIPELINE DE TRAITEMENT PYSPARK (DATABRICKS)</a:t>
             </a:r>
-            <a:endParaRPr/>
+            <a:endParaRPr sz="1800"/>
           </a:p>
           <a:p>
             <a:pPr indent="0" lvl="0" marL="0" marR="0" rtl="0" algn="l">
@@ -12616,7 +12607,7 @@
               <a:buNone/>
             </a:pPr>
             <a:r>
-              <a:rPr b="1" i="0" lang="en-US" sz="1100" u="none" cap="none" strike="noStrike">
+              <a:rPr b="1" i="0" lang="en-US" sz="1500" u="none" cap="none" strike="noStrike">
                 <a:solidFill>
                   <a:srgbClr val="F8FAFC"/>
                 </a:solidFill>
@@ -12627,7 +12618,7 @@
               </a:rPr>
               <a:t>Aplatissement Struct (data.*) :</a:t>
             </a:r>
-            <a:endParaRPr/>
+            <a:endParaRPr sz="1800"/>
           </a:p>
           <a:p>
             <a:pPr indent="0" lvl="0" marL="0" marR="0" rtl="0" algn="l">
@@ -12640,7 +12631,7 @@
               <a:buNone/>
             </a:pPr>
             <a:r>
-              <a:rPr b="0" i="0" lang="en-US" sz="1000" u="none" cap="none" strike="noStrike">
+              <a:rPr b="0" i="0" lang="en-US" u="none" cap="none" strike="noStrike">
                 <a:solidFill>
                   <a:srgbClr val="94A3B8"/>
                 </a:solidFill>
@@ -12651,7 +12642,7 @@
               </a:rPr>
               <a:t>Dé-imbrication automatique de 22 attributs racines depuis la structure complexe 'data'.</a:t>
             </a:r>
-            <a:endParaRPr/>
+            <a:endParaRPr sz="1800"/>
           </a:p>
           <a:p>
             <a:pPr indent="0" lvl="0" marL="0" marR="0" rtl="0" algn="l">
@@ -12664,7 +12655,7 @@
               <a:buNone/>
             </a:pPr>
             <a:r>
-              <a:rPr b="1" i="0" lang="en-US" sz="1100" u="none" cap="none" strike="noStrike">
+              <a:rPr b="1" i="0" lang="en-US" sz="1500" u="none" cap="none" strike="noStrike">
                 <a:solidFill>
                   <a:srgbClr val="F8FAFC"/>
                 </a:solidFill>
@@ -12675,7 +12666,7 @@
               </a:rPr>
               <a:t>Fonctions de Résilience :</a:t>
             </a:r>
-            <a:endParaRPr/>
+            <a:endParaRPr sz="1800"/>
           </a:p>
           <a:p>
             <a:pPr indent="0" lvl="0" marL="0" marR="0" rtl="0" algn="l">
@@ -12688,7 +12679,7 @@
               <a:buNone/>
             </a:pPr>
             <a:r>
-              <a:rPr b="0" i="0" lang="en-US" sz="1000" u="none" cap="none" strike="noStrike">
+              <a:rPr b="0" i="0" lang="en-US" u="none" cap="none" strike="noStrike">
                 <a:solidFill>
                   <a:srgbClr val="94A3B8"/>
                 </a:solidFill>
@@ -12699,7 +12690,7 @@
               </a:rPr>
               <a:t>Implémentation de first_existing_col() pour garantir l'extraction des prix, genres et dates quel que soit le schéma.</a:t>
             </a:r>
-            <a:endParaRPr/>
+            <a:endParaRPr sz="1800"/>
           </a:p>
           <a:p>
             <a:pPr indent="0" lvl="0" marL="0" marR="0" rtl="0" algn="l">
@@ -12712,7 +12703,7 @@
               <a:buNone/>
             </a:pPr>
             <a:r>
-              <a:rPr b="1" i="0" lang="en-US" sz="1100" u="none" cap="none" strike="noStrike">
+              <a:rPr b="1" i="0" lang="en-US" sz="1500" u="none" cap="none" strike="noStrike">
                 <a:solidFill>
                   <a:srgbClr val="F8FAFC"/>
                 </a:solidFill>
@@ -12723,7 +12714,7 @@
               </a:rPr>
               <a:t>Nettoyage &amp; Typage Distribué :</a:t>
             </a:r>
-            <a:endParaRPr/>
+            <a:endParaRPr sz="1800"/>
           </a:p>
           <a:p>
             <a:pPr indent="0" lvl="0" marL="0" marR="0" rtl="0" algn="l">
@@ -12736,7 +12727,7 @@
               <a:buNone/>
             </a:pPr>
             <a:r>
-              <a:rPr b="0" i="0" lang="en-US" sz="1000" u="none" cap="none" strike="noStrike">
+              <a:rPr b="0" i="0" lang="en-US" u="none" cap="none" strike="noStrike">
                 <a:solidFill>
                   <a:srgbClr val="94A3B8"/>
                 </a:solidFill>
@@ -12747,7 +12738,7 @@
               </a:rPr>
               <a:t>Conversion des centimes en euros (price / 100), détection de is_free, parsing multi-formats des dates via try_to_date().</a:t>
             </a:r>
-            <a:endParaRPr/>
+            <a:endParaRPr sz="1800"/>
           </a:p>
           <a:p>
             <a:pPr indent="0" lvl="0" marL="0" marR="0" rtl="0" algn="l">
@@ -12760,7 +12751,7 @@
               <a:buNone/>
             </a:pPr>
             <a:r>
-              <a:rPr b="1" i="0" lang="en-US" sz="1100" u="none" cap="none" strike="noStrike">
+              <a:rPr b="1" i="0" lang="en-US" sz="1500" u="none" cap="none" strike="noStrike">
                 <a:solidFill>
                   <a:srgbClr val="F8FAFC"/>
                 </a:solidFill>
@@ -12771,7 +12762,7 @@
               </a:rPr>
               <a:t>Optimisation Catalyst :</a:t>
             </a:r>
-            <a:endParaRPr/>
+            <a:endParaRPr sz="1800"/>
           </a:p>
           <a:p>
             <a:pPr indent="0" lvl="0" marL="0" marR="0" rtl="0" algn="l">
@@ -12784,7 +12775,7 @@
               <a:buNone/>
             </a:pPr>
             <a:r>
-              <a:rPr b="0" i="0" lang="en-US" sz="1000" u="none" cap="none" strike="noStrike">
+              <a:rPr b="0" i="0" lang="en-US" u="none" cap="none" strike="noStrike">
                 <a:solidFill>
                   <a:srgbClr val="94A3B8"/>
                 </a:solidFill>
@@ -12795,7 +12786,7 @@
               </a:rPr>
               <a:t>Calcul vectoriel des ratios d'avis (positive_ratio) et décomposition des listes via explode_outer().</a:t>
             </a:r>
-            <a:endParaRPr/>
+            <a:endParaRPr sz="1800"/>
           </a:p>
         </p:txBody>
       </p:sp>
@@ -12891,7 +12882,7 @@
         <p:spPr>
           <a:xfrm>
             <a:off x="731520" y="365760"/>
-            <a:ext cx="7315200" cy="200100"/>
+            <a:ext cx="7315200" cy="277200"/>
           </a:xfrm>
           <a:prstGeom prst="rect">
             <a:avLst/>
@@ -12917,7 +12908,7 @@
               <a:buNone/>
             </a:pPr>
             <a:r>
-              <a:rPr b="1" i="0" lang="en-US" sz="1300" u="none" cap="none" strike="noStrike">
+              <a:rPr b="1" i="0" lang="en-US" sz="1800" u="none" cap="none" strike="noStrike">
                 <a:solidFill>
                   <a:srgbClr val="38BDF8"/>
                 </a:solidFill>
@@ -12928,7 +12919,7 @@
               </a:rPr>
               <a:t>ÉTAPE 02 | EXPLORATION TEMPORELLE</a:t>
             </a:r>
-            <a:endParaRPr sz="1600"/>
+            <a:endParaRPr sz="2100"/>
           </a:p>
         </p:txBody>
       </p:sp>
@@ -13041,7 +13032,7 @@
         <p:spPr>
           <a:xfrm>
             <a:off x="731520" y="6400800"/>
-            <a:ext cx="10728655" cy="274320"/>
+            <a:ext cx="10728600" cy="215400"/>
           </a:xfrm>
           <a:prstGeom prst="rect">
             <a:avLst/>
@@ -13067,16 +13058,7 @@
               <a:buNone/>
             </a:pPr>
             <a:r>
-              <a:rPr b="0" i="0" lang="en-US" sz="950" u="none" cap="none" strike="noStrike">
-                <a:solidFill>
-                  <a:srgbClr val="94A3B8"/>
-                </a:solidFill>
-                <a:latin typeface="Quattrocento Sans"/>
-                <a:ea typeface="Quattrocento Sans"/>
-                <a:cs typeface="Quattrocento Sans"/>
-                <a:sym typeface="Quattrocento Sans"/>
-              </a:rPr>
-              <a:t>Christopher GILLERON  |  Steam Video Games Analysis (PySpark / Databricks)  |  Certification CDSD Bloc 2  |  Temps alloué : 5 min</a:t>
+              <a:t/>
             </a:r>
             <a:endParaRPr/>
           </a:p>
@@ -13859,7 +13841,7 @@
         <p:spPr>
           <a:xfrm>
             <a:off x="731520" y="365760"/>
-            <a:ext cx="7315200" cy="215400"/>
+            <a:ext cx="7315200" cy="292500"/>
           </a:xfrm>
           <a:prstGeom prst="rect">
             <a:avLst/>
@@ -13885,7 +13867,7 @@
               <a:buNone/>
             </a:pPr>
             <a:r>
-              <a:rPr b="1" i="0" lang="en-US" u="none" cap="none" strike="noStrike">
+              <a:rPr b="1" i="0" lang="en-US" sz="1900" u="none" cap="none" strike="noStrike">
                 <a:solidFill>
                   <a:srgbClr val="38BDF8"/>
                 </a:solidFill>
@@ -13896,7 +13878,7 @@
               </a:rPr>
               <a:t>ÉTAPE 03 | PANORAMA CONCURRENTIEL</a:t>
             </a:r>
-            <a:endParaRPr sz="1700"/>
+            <a:endParaRPr sz="2200"/>
           </a:p>
         </p:txBody>
       </p:sp>
@@ -14009,7 +13991,7 @@
         <p:spPr>
           <a:xfrm>
             <a:off x="731520" y="6400800"/>
-            <a:ext cx="10728600" cy="192300"/>
+            <a:ext cx="10728600" cy="261600"/>
           </a:xfrm>
           <a:prstGeom prst="rect">
             <a:avLst/>
@@ -14035,16 +14017,7 @@
               <a:buNone/>
             </a:pPr>
             <a:r>
-              <a:rPr b="0" i="0" lang="en-US" sz="1250" u="none" cap="none" strike="noStrike">
-                <a:solidFill>
-                  <a:srgbClr val="94A3B8"/>
-                </a:solidFill>
-                <a:latin typeface="Quattrocento Sans"/>
-                <a:ea typeface="Quattrocento Sans"/>
-                <a:cs typeface="Quattrocento Sans"/>
-                <a:sym typeface="Quattrocento Sans"/>
-              </a:rPr>
-              <a:t>Christopher GILLERON  |  Steam Video Games Analysis (PySpark / Databricks)  |  Certification CDSD Bloc 2  |  Temps alloué : 5 min</a:t>
+              <a:t/>
             </a:r>
             <a:endParaRPr sz="1700"/>
           </a:p>
@@ -14124,7 +14097,7 @@
         </p:nvSpPr>
         <p:spPr>
           <a:xfrm>
-            <a:off x="914400" y="1554480"/>
+            <a:off x="1027775" y="1849205"/>
             <a:ext cx="4846200" cy="2647500"/>
           </a:xfrm>
           <a:prstGeom prst="rect">
@@ -14854,7 +14827,7 @@
         <p:spPr>
           <a:xfrm>
             <a:off x="731520" y="365760"/>
-            <a:ext cx="7315200" cy="215400"/>
+            <a:ext cx="7315200" cy="292500"/>
           </a:xfrm>
           <a:prstGeom prst="rect">
             <a:avLst/>
@@ -14880,7 +14853,7 @@
               <a:buNone/>
             </a:pPr>
             <a:r>
-              <a:rPr b="1" i="0" lang="en-US" u="none" cap="none" strike="noStrike">
+              <a:rPr b="1" i="0" lang="en-US" sz="1900" u="none" cap="none" strike="noStrike">
                 <a:solidFill>
                   <a:srgbClr val="38BDF8"/>
                 </a:solidFill>
@@ -14891,7 +14864,7 @@
               </a:rPr>
               <a:t>ÉTAPE 04 | MODÈLES ÉCONOMIQUES</a:t>
             </a:r>
-            <a:endParaRPr sz="1700"/>
+            <a:endParaRPr sz="2200"/>
           </a:p>
         </p:txBody>
       </p:sp>
@@ -15004,7 +14977,7 @@
         <p:spPr>
           <a:xfrm>
             <a:off x="731520" y="6400800"/>
-            <a:ext cx="10728600" cy="274200"/>
+            <a:ext cx="10728600" cy="215400"/>
           </a:xfrm>
           <a:prstGeom prst="rect">
             <a:avLst/>
@@ -15030,16 +15003,7 @@
               <a:buNone/>
             </a:pPr>
             <a:r>
-              <a:rPr b="0" i="0" lang="en-US" sz="950" u="none" cap="none" strike="noStrike">
-                <a:solidFill>
-                  <a:srgbClr val="94A3B8"/>
-                </a:solidFill>
-                <a:latin typeface="Quattrocento Sans"/>
-                <a:ea typeface="Quattrocento Sans"/>
-                <a:cs typeface="Quattrocento Sans"/>
-                <a:sym typeface="Quattrocento Sans"/>
-              </a:rPr>
-              <a:t>Christopher GILLERON  |  Steam Video Games Analysis (PySpark / Databricks)  |  Certification CDSD Bloc 2  |  Temps alloué : 5 min</a:t>
+              <a:t/>
             </a:r>
             <a:endParaRPr/>
           </a:p>
@@ -15822,7 +15786,7 @@
         <p:spPr>
           <a:xfrm>
             <a:off x="731520" y="365760"/>
-            <a:ext cx="7315200" cy="215400"/>
+            <a:ext cx="7315200" cy="292500"/>
           </a:xfrm>
           <a:prstGeom prst="rect">
             <a:avLst/>
@@ -15848,7 +15812,7 @@
               <a:buNone/>
             </a:pPr>
             <a:r>
-              <a:rPr b="1" i="0" lang="en-US" u="none" cap="none" strike="noStrike">
+              <a:rPr b="1" i="0" lang="en-US" sz="1900" u="none" cap="none" strike="noStrike">
                 <a:solidFill>
                   <a:srgbClr val="38BDF8"/>
                 </a:solidFill>
@@ -15859,7 +15823,7 @@
               </a:rPr>
               <a:t>ÉTAPE 05 | ANALYSE DES GENRES &amp; QUALITÉ</a:t>
             </a:r>
-            <a:endParaRPr sz="1700"/>
+            <a:endParaRPr sz="2200"/>
           </a:p>
         </p:txBody>
       </p:sp>
@@ -15972,7 +15936,7 @@
         <p:spPr>
           <a:xfrm>
             <a:off x="731520" y="6400800"/>
-            <a:ext cx="10728600" cy="146100"/>
+            <a:ext cx="10728600" cy="215400"/>
           </a:xfrm>
           <a:prstGeom prst="rect">
             <a:avLst/>
@@ -15998,16 +15962,7 @@
               <a:buNone/>
             </a:pPr>
             <a:r>
-              <a:rPr b="0" i="0" lang="en-US" sz="950" u="none" cap="none" strike="noStrike">
-                <a:solidFill>
-                  <a:srgbClr val="94A3B8"/>
-                </a:solidFill>
-                <a:latin typeface="Quattrocento Sans"/>
-                <a:ea typeface="Quattrocento Sans"/>
-                <a:cs typeface="Quattrocento Sans"/>
-                <a:sym typeface="Quattrocento Sans"/>
-              </a:rPr>
-              <a:t>Christopher GILLERON  |  Steam Video Games Analysis (PySpark / Databricks)  |  Certification CDSD Bloc 2  |  Temps alloué : 5 min</a:t>
+              <a:t/>
             </a:r>
             <a:endParaRPr/>
           </a:p>
@@ -16817,7 +16772,7 @@
         <p:spPr>
           <a:xfrm>
             <a:off x="731520" y="365760"/>
-            <a:ext cx="7315200" cy="215400"/>
+            <a:ext cx="7315200" cy="307800"/>
           </a:xfrm>
           <a:prstGeom prst="rect">
             <a:avLst/>
@@ -16843,7 +16798,7 @@
               <a:buNone/>
             </a:pPr>
             <a:r>
-              <a:rPr b="1" i="0" lang="en-US" u="none" cap="none" strike="noStrike">
+              <a:rPr b="1" i="0" lang="en-US" sz="2000" u="none" cap="none" strike="noStrike">
                 <a:solidFill>
                   <a:srgbClr val="38BDF8"/>
                 </a:solidFill>
@@ -16854,7 +16809,7 @@
               </a:rPr>
               <a:t>ÉTAPE 06 | RENTABILITÉ &amp; ÉCOSYSTÈME</a:t>
             </a:r>
-            <a:endParaRPr sz="1700"/>
+            <a:endParaRPr sz="2300"/>
           </a:p>
         </p:txBody>
       </p:sp>
@@ -16967,7 +16922,7 @@
         <p:spPr>
           <a:xfrm>
             <a:off x="731520" y="6400800"/>
-            <a:ext cx="10728655" cy="274320"/>
+            <a:ext cx="10728600" cy="215400"/>
           </a:xfrm>
           <a:prstGeom prst="rect">
             <a:avLst/>
@@ -16993,16 +16948,7 @@
               <a:buNone/>
             </a:pPr>
             <a:r>
-              <a:rPr b="0" i="0" lang="en-US" sz="950" u="none" cap="none" strike="noStrike">
-                <a:solidFill>
-                  <a:srgbClr val="94A3B8"/>
-                </a:solidFill>
-                <a:latin typeface="Quattrocento Sans"/>
-                <a:ea typeface="Quattrocento Sans"/>
-                <a:cs typeface="Quattrocento Sans"/>
-                <a:sym typeface="Quattrocento Sans"/>
-              </a:rPr>
-              <a:t>Christopher GILLERON  |  Steam Video Games Analysis (PySpark / Databricks)  |  Certification CDSD Bloc 2  |  Temps alloué : 5 min</a:t>
+              <a:t/>
             </a:r>
             <a:endParaRPr/>
           </a:p>
@@ -17764,7 +17710,7 @@
             <a:r>
               <a:t/>
             </a:r>
-            <a:endParaRPr b="0" i="0" sz="1800" u="none" cap="none" strike="noStrike">
+            <a:endParaRPr b="0" i="0" sz="2400" u="none" cap="none" strike="noStrike">
               <a:solidFill>
                 <a:schemeClr val="dk1"/>
               </a:solidFill>
@@ -17785,7 +17731,7 @@
         <p:spPr>
           <a:xfrm>
             <a:off x="731520" y="365760"/>
-            <a:ext cx="7315200" cy="320040"/>
+            <a:ext cx="7315200" cy="261600"/>
           </a:xfrm>
           <a:prstGeom prst="rect">
             <a:avLst/>
@@ -17811,7 +17757,7 @@
               <a:buNone/>
             </a:pPr>
             <a:r>
-              <a:rPr b="1" i="0" lang="en-US" sz="1100" u="none" cap="none" strike="noStrike">
+              <a:rPr b="1" i="0" lang="en-US" sz="1700" u="none" cap="none" strike="noStrike">
                 <a:solidFill>
                   <a:srgbClr val="38BDF8"/>
                 </a:solidFill>
@@ -17822,7 +17768,7 @@
               </a:rPr>
               <a:t>ÉTAPE 07 | PLAN D'ACTION &amp; SYNTHÈSE</a:t>
             </a:r>
-            <a:endParaRPr/>
+            <a:endParaRPr sz="2000"/>
           </a:p>
         </p:txBody>
       </p:sp>
@@ -17835,7 +17781,7 @@
         <p:spPr>
           <a:xfrm>
             <a:off x="731520" y="685800"/>
-            <a:ext cx="9601200" cy="502920"/>
+            <a:ext cx="9601200" cy="369300"/>
           </a:xfrm>
           <a:prstGeom prst="rect">
             <a:avLst/>
@@ -17861,7 +17807,7 @@
               <a:buNone/>
             </a:pPr>
             <a:r>
-              <a:rPr b="1" i="0" lang="en-US" sz="1800" u="none" cap="none" strike="noStrike">
+              <a:rPr b="1" i="0" lang="en-US" sz="2400" u="none" cap="none" strike="noStrike">
                 <a:solidFill>
                   <a:srgbClr val="F8FAFC"/>
                 </a:solidFill>
@@ -17872,7 +17818,7 @@
               </a:rPr>
               <a:t>4 Recommandations Stratégiques Clés pour Ubisoft</a:t>
             </a:r>
-            <a:endParaRPr/>
+            <a:endParaRPr sz="2000"/>
           </a:p>
         </p:txBody>
       </p:sp>
@@ -17885,7 +17831,7 @@
         <p:spPr>
           <a:xfrm>
             <a:off x="10362895" y="411480"/>
-            <a:ext cx="1097280" cy="365760"/>
+            <a:ext cx="1097400" cy="277200"/>
           </a:xfrm>
           <a:prstGeom prst="rect">
             <a:avLst/>
@@ -17911,7 +17857,7 @@
               <a:buNone/>
             </a:pPr>
             <a:r>
-              <a:rPr b="1" i="0" lang="en-US" sz="1200" u="none" cap="none" strike="noStrike">
+              <a:rPr b="1" i="0" lang="en-US" sz="1800" u="none" cap="none" strike="noStrike">
                 <a:solidFill>
                   <a:srgbClr val="94A3B8"/>
                 </a:solidFill>
@@ -17922,7 +17868,7 @@
               </a:rPr>
               <a:t>8 / 8</a:t>
             </a:r>
-            <a:endParaRPr/>
+            <a:endParaRPr sz="2000"/>
           </a:p>
         </p:txBody>
       </p:sp>
@@ -17935,7 +17881,7 @@
         <p:spPr>
           <a:xfrm>
             <a:off x="731520" y="6400800"/>
-            <a:ext cx="10728655" cy="274320"/>
+            <a:ext cx="10728600" cy="307800"/>
           </a:xfrm>
           <a:prstGeom prst="rect">
             <a:avLst/>
@@ -17961,18 +17907,9 @@
               <a:buNone/>
             </a:pPr>
             <a:r>
-              <a:rPr b="0" i="0" lang="en-US" sz="950" u="none" cap="none" strike="noStrike">
-                <a:solidFill>
-                  <a:srgbClr val="94A3B8"/>
-                </a:solidFill>
-                <a:latin typeface="Quattrocento Sans"/>
-                <a:ea typeface="Quattrocento Sans"/>
-                <a:cs typeface="Quattrocento Sans"/>
-                <a:sym typeface="Quattrocento Sans"/>
-              </a:rPr>
-              <a:t>Christopher GILLERON  |  Steam Video Games Analysis (PySpark / Databricks)  |  Certification CDSD Bloc 2  |  Temps alloué : 5 min</a:t>
-            </a:r>
-            <a:endParaRPr/>
+              <a:t/>
+            </a:r>
+            <a:endParaRPr sz="2000"/>
           </a:p>
         </p:txBody>
       </p:sp>
@@ -18030,7 +17967,7 @@
             <a:r>
               <a:t/>
             </a:r>
-            <a:endParaRPr b="0" i="0" sz="1800" u="none" cap="none" strike="noStrike">
+            <a:endParaRPr b="0" i="0" sz="2400" u="none" cap="none" strike="noStrike">
               <a:solidFill>
                 <a:schemeClr val="dk1"/>
               </a:solidFill>
@@ -18051,7 +17988,7 @@
         <p:spPr>
           <a:xfrm>
             <a:off x="914400" y="1508760"/>
-            <a:ext cx="4846320" cy="2011680"/>
+            <a:ext cx="4846200" cy="1944600"/>
           </a:xfrm>
           <a:prstGeom prst="rect">
             <a:avLst/>
@@ -18077,7 +18014,7 @@
               <a:buNone/>
             </a:pPr>
             <a:r>
-              <a:rPr b="1" i="0" lang="en-US" sz="1200" u="none" cap="none" strike="noStrike">
+              <a:rPr b="1" i="0" lang="en-US" sz="1800" u="none" cap="none" strike="noStrike">
                 <a:solidFill>
                   <a:srgbClr val="38BDF8"/>
                 </a:solidFill>
@@ -18088,7 +18025,7 @@
               </a:rPr>
               <a:t>01 | POSITIONNEMENT PRIX : 24.99 € - 29.99 €</a:t>
             </a:r>
-            <a:endParaRPr/>
+            <a:endParaRPr sz="2000"/>
           </a:p>
           <a:p>
             <a:pPr indent="0" lvl="0" marL="0" marR="0" rtl="0" algn="l">
@@ -18101,7 +18038,7 @@
               <a:buNone/>
             </a:pPr>
             <a:r>
-              <a:rPr b="1" i="0" lang="en-US" sz="1000" u="none" cap="none" strike="noStrike">
+              <a:rPr b="1" i="0" lang="en-US" sz="1600" u="none" cap="none" strike="noStrike">
                 <a:solidFill>
                   <a:srgbClr val="F8FAFC"/>
                 </a:solidFill>
@@ -18112,7 +18049,7 @@
               </a:rPr>
               <a:t>Justification Data :</a:t>
             </a:r>
-            <a:endParaRPr/>
+            <a:endParaRPr sz="2000"/>
           </a:p>
           <a:p>
             <a:pPr indent="0" lvl="0" marL="0" marR="0" rtl="0" algn="l">
@@ -18125,7 +18062,7 @@
               <a:buNone/>
             </a:pPr>
             <a:r>
-              <a:rPr b="0" i="0" lang="en-US" sz="950" u="none" cap="none" strike="noStrike">
+              <a:rPr b="0" i="0" lang="en-US" sz="1550" u="none" cap="none" strike="noStrike">
                 <a:solidFill>
                   <a:srgbClr val="94A3B8"/>
                 </a:solidFill>
@@ -18136,7 +18073,7 @@
               </a:rPr>
               <a:t>Évite la guerre des prix de l'ultra-budget (&lt;15€) tout en abaissant la barrière psychologique des 60€+.</a:t>
             </a:r>
-            <a:endParaRPr/>
+            <a:endParaRPr sz="2000"/>
           </a:p>
           <a:p>
             <a:pPr indent="0" lvl="0" marL="0" marR="0" rtl="0" algn="l">
@@ -18149,7 +18086,7 @@
               <a:buNone/>
             </a:pPr>
             <a:r>
-              <a:rPr b="1" i="0" lang="en-US" sz="1000" u="none" cap="none" strike="noStrike">
+              <a:rPr b="1" i="0" lang="en-US" sz="1600" u="none" cap="none" strike="noStrike">
                 <a:solidFill>
                   <a:srgbClr val="F8FAFC"/>
                 </a:solidFill>
@@ -18160,7 +18097,7 @@
               </a:rPr>
               <a:t>Upsell :</a:t>
             </a:r>
-            <a:endParaRPr/>
+            <a:endParaRPr sz="2000"/>
           </a:p>
           <a:p>
             <a:pPr indent="0" lvl="0" marL="0" marR="0" rtl="0" algn="l">
@@ -18173,7 +18110,7 @@
               <a:buNone/>
             </a:pPr>
             <a:r>
-              <a:rPr b="0" i="0" lang="en-US" sz="950" u="none" cap="none" strike="noStrike">
+              <a:rPr b="0" i="0" lang="en-US" sz="1550" u="none" cap="none" strike="noStrike">
                 <a:solidFill>
                   <a:srgbClr val="94A3B8"/>
                 </a:solidFill>
@@ -18184,7 +18121,7 @@
               </a:rPr>
               <a:t>Proposer une Édition Deluxe à 39.99€ avec cosmétiques exclusifs.</a:t>
             </a:r>
-            <a:endParaRPr/>
+            <a:endParaRPr sz="2000"/>
           </a:p>
         </p:txBody>
       </p:sp>
@@ -18242,7 +18179,7 @@
             <a:r>
               <a:t/>
             </a:r>
-            <a:endParaRPr b="0" i="0" sz="1800" u="none" cap="none" strike="noStrike">
+            <a:endParaRPr b="0" i="0" sz="2400" u="none" cap="none" strike="noStrike">
               <a:solidFill>
                 <a:schemeClr val="dk1"/>
               </a:solidFill>
@@ -18263,7 +18200,7 @@
         <p:spPr>
           <a:xfrm>
             <a:off x="6400800" y="1508760"/>
-            <a:ext cx="4846320" cy="2011680"/>
+            <a:ext cx="4846200" cy="1944600"/>
           </a:xfrm>
           <a:prstGeom prst="rect">
             <a:avLst/>
@@ -18289,7 +18226,7 @@
               <a:buNone/>
             </a:pPr>
             <a:r>
-              <a:rPr b="1" i="0" lang="en-US" sz="1200" u="none" cap="none" strike="noStrike">
+              <a:rPr b="1" i="0" lang="en-US" sz="1800" u="none" cap="none" strike="noStrike">
                 <a:solidFill>
                   <a:srgbClr val="10B981"/>
                 </a:solidFill>
@@ -18300,7 +18237,7 @@
               </a:rPr>
               <a:t>02 | GENRE CIBLE : L'ACTION-RPG HYBRIDE</a:t>
             </a:r>
-            <a:endParaRPr/>
+            <a:endParaRPr sz="2000"/>
           </a:p>
           <a:p>
             <a:pPr indent="0" lvl="0" marL="0" marR="0" rtl="0" algn="l">
@@ -18313,7 +18250,7 @@
               <a:buNone/>
             </a:pPr>
             <a:r>
-              <a:rPr b="1" i="0" lang="en-US" sz="1000" u="none" cap="none" strike="noStrike">
+              <a:rPr b="1" i="0" lang="en-US" sz="1600" u="none" cap="none" strike="noStrike">
                 <a:solidFill>
                   <a:srgbClr val="F8FAFC"/>
                 </a:solidFill>
@@ -18324,7 +18261,7 @@
               </a:rPr>
               <a:t>Justification Data :</a:t>
             </a:r>
-            <a:endParaRPr/>
+            <a:endParaRPr sz="2000"/>
           </a:p>
           <a:p>
             <a:pPr indent="0" lvl="0" marL="0" marR="0" rtl="0" algn="l">
@@ -18337,7 +18274,7 @@
               <a:buNone/>
             </a:pPr>
             <a:r>
-              <a:rPr b="0" i="0" lang="en-US" sz="950" u="none" cap="none" strike="noStrike">
+              <a:rPr b="0" i="0" lang="en-US" sz="1550" u="none" cap="none" strike="noStrike">
                 <a:solidFill>
                   <a:srgbClr val="94A3B8"/>
                 </a:solidFill>
@@ -18348,7 +18285,7 @@
               </a:rPr>
               <a:t>Action = 1er proxy revenus (1.05 Md€). RPG = prix moyen le plus élevé (9.04€) et 73% de satisfaction.</a:t>
             </a:r>
-            <a:endParaRPr/>
+            <a:endParaRPr sz="2000"/>
           </a:p>
           <a:p>
             <a:pPr indent="0" lvl="0" marL="0" marR="0" rtl="0" algn="l">
@@ -18361,7 +18298,7 @@
               <a:buNone/>
             </a:pPr>
             <a:r>
-              <a:rPr b="1" i="0" lang="en-US" sz="1000" u="none" cap="none" strike="noStrike">
+              <a:rPr b="1" i="0" lang="en-US" sz="1600" u="none" cap="none" strike="noStrike">
                 <a:solidFill>
                   <a:srgbClr val="F8FAFC"/>
                 </a:solidFill>
@@ -18372,7 +18309,7 @@
               </a:rPr>
               <a:t>Atout :</a:t>
             </a:r>
-            <a:endParaRPr/>
+            <a:endParaRPr sz="2000"/>
           </a:p>
           <a:p>
             <a:pPr indent="0" lvl="0" marL="0" marR="0" rtl="0" algn="l">
@@ -18385,7 +18322,7 @@
               <a:buNone/>
             </a:pPr>
             <a:r>
-              <a:rPr b="0" i="0" lang="en-US" sz="950" u="none" cap="none" strike="noStrike">
+              <a:rPr b="0" i="0" lang="en-US" sz="1550" u="none" cap="none" strike="noStrike">
                 <a:solidFill>
                   <a:srgbClr val="94A3B8"/>
                 </a:solidFill>
@@ -18396,7 +18333,7 @@
               </a:rPr>
               <a:t>Progression de personnage profonde et forte rétention multijoueur.</a:t>
             </a:r>
-            <a:endParaRPr/>
+            <a:endParaRPr sz="2000"/>
           </a:p>
         </p:txBody>
       </p:sp>
@@ -18454,7 +18391,7 @@
             <a:r>
               <a:t/>
             </a:r>
-            <a:endParaRPr b="0" i="0" sz="1800" u="none" cap="none" strike="noStrike">
+            <a:endParaRPr b="0" i="0" sz="2400" u="none" cap="none" strike="noStrike">
               <a:solidFill>
                 <a:schemeClr val="dk1"/>
               </a:solidFill>
@@ -18475,7 +18412,7 @@
         <p:spPr>
           <a:xfrm>
             <a:off x="914400" y="4069080"/>
-            <a:ext cx="4846320" cy="2011680"/>
+            <a:ext cx="4846200" cy="1944600"/>
           </a:xfrm>
           <a:prstGeom prst="rect">
             <a:avLst/>
@@ -18501,7 +18438,7 @@
               <a:buNone/>
             </a:pPr>
             <a:r>
-              <a:rPr b="1" i="0" lang="en-US" sz="1200" u="none" cap="none" strike="noStrike">
+              <a:rPr b="1" i="0" lang="en-US" sz="1800" u="none" cap="none" strike="noStrike">
                 <a:solidFill>
                   <a:srgbClr val="F59E0B"/>
                 </a:solidFill>
@@ -18512,7 +18449,7 @@
               </a:rPr>
               <a:t>03 | CALENDRIER DES SOLDES PROGRESSIF</a:t>
             </a:r>
-            <a:endParaRPr/>
+            <a:endParaRPr sz="2000"/>
           </a:p>
           <a:p>
             <a:pPr indent="0" lvl="0" marL="0" marR="0" rtl="0" algn="l">
@@ -18525,7 +18462,7 @@
               <a:buNone/>
             </a:pPr>
             <a:r>
-              <a:rPr b="1" i="0" lang="en-US" sz="1000" u="none" cap="none" strike="noStrike">
+              <a:rPr b="1" i="0" lang="en-US" sz="1600" u="none" cap="none" strike="noStrike">
                 <a:solidFill>
                   <a:srgbClr val="F8FAFC"/>
                 </a:solidFill>
@@ -18536,7 +18473,7 @@
               </a:rPr>
               <a:t>Protection Lancement :</a:t>
             </a:r>
-            <a:endParaRPr/>
+            <a:endParaRPr sz="2000"/>
           </a:p>
           <a:p>
             <a:pPr indent="0" lvl="0" marL="0" marR="0" rtl="0" algn="l">
@@ -18549,7 +18486,7 @@
               <a:buNone/>
             </a:pPr>
             <a:r>
-              <a:rPr b="0" i="0" lang="en-US" sz="950" u="none" cap="none" strike="noStrike">
+              <a:rPr b="0" i="0" lang="en-US" sz="1550" u="none" cap="none" strike="noStrike">
                 <a:solidFill>
                   <a:srgbClr val="94A3B8"/>
                 </a:solidFill>
@@ -18560,7 +18497,7 @@
               </a:rPr>
               <a:t>Aucune promotion avant 90 jours pour préserver les marges Day One.</a:t>
             </a:r>
-            <a:endParaRPr/>
+            <a:endParaRPr sz="2000"/>
           </a:p>
           <a:p>
             <a:pPr indent="0" lvl="0" marL="0" marR="0" rtl="0" algn="l">
@@ -18573,7 +18510,7 @@
               <a:buNone/>
             </a:pPr>
             <a:r>
-              <a:rPr b="1" i="0" lang="en-US" sz="1000" u="none" cap="none" strike="noStrike">
+              <a:rPr b="1" i="0" lang="en-US" sz="1600" u="none" cap="none" strike="noStrike">
                 <a:solidFill>
                   <a:srgbClr val="F8FAFC"/>
                 </a:solidFill>
@@ -18584,7 +18521,7 @@
               </a:rPr>
               <a:t>Élasticité :</a:t>
             </a:r>
-            <a:endParaRPr/>
+            <a:endParaRPr sz="2000"/>
           </a:p>
           <a:p>
             <a:pPr indent="0" lvl="0" marL="0" marR="0" rtl="0" algn="l">
@@ -18597,7 +18534,7 @@
               <a:buNone/>
             </a:pPr>
             <a:r>
-              <a:rPr b="0" i="0" lang="en-US" sz="950" u="none" cap="none" strike="noStrike">
+              <a:rPr b="0" i="0" lang="en-US" sz="1550" u="none" cap="none" strike="noStrike">
                 <a:solidFill>
                   <a:srgbClr val="94A3B8"/>
                 </a:solidFill>
@@ -18608,7 +18545,7 @@
               </a:rPr>
               <a:t>Participer aux Soldes d'Hiver avec -25% pour convertir les Wishlists accumulées.</a:t>
             </a:r>
-            <a:endParaRPr/>
+            <a:endParaRPr sz="2000"/>
           </a:p>
         </p:txBody>
       </p:sp>
@@ -18666,7 +18603,7 @@
             <a:r>
               <a:t/>
             </a:r>
-            <a:endParaRPr b="0" i="0" sz="1800" u="none" cap="none" strike="noStrike">
+            <a:endParaRPr b="0" i="0" sz="2400" u="none" cap="none" strike="noStrike">
               <a:solidFill>
                 <a:schemeClr val="dk1"/>
               </a:solidFill>
@@ -18687,7 +18624,7 @@
         <p:spPr>
           <a:xfrm>
             <a:off x="6400800" y="4069080"/>
-            <a:ext cx="4846320" cy="2011680"/>
+            <a:ext cx="4846200" cy="1944600"/>
           </a:xfrm>
           <a:prstGeom prst="rect">
             <a:avLst/>
@@ -18713,7 +18650,7 @@
               <a:buNone/>
             </a:pPr>
             <a:r>
-              <a:rPr b="1" i="0" lang="en-US" sz="1200" u="none" cap="none" strike="noStrike">
+              <a:rPr b="1" i="0" lang="en-US" sz="1800" u="none" cap="none" strike="noStrike">
                 <a:solidFill>
                   <a:srgbClr val="A855F7"/>
                 </a:solidFill>
@@ -18724,7 +18661,7 @@
               </a:rPr>
               <a:t>04 | STEAM DECK &amp; DOUBLAGE ASIATIQUE</a:t>
             </a:r>
-            <a:endParaRPr/>
+            <a:endParaRPr sz="2000"/>
           </a:p>
           <a:p>
             <a:pPr indent="0" lvl="0" marL="0" marR="0" rtl="0" algn="l">
@@ -18737,7 +18674,7 @@
               <a:buNone/>
             </a:pPr>
             <a:r>
-              <a:rPr b="1" i="0" lang="en-US" sz="1000" u="none" cap="none" strike="noStrike">
+              <a:rPr b="1" i="0" lang="en-US" sz="1600" u="none" cap="none" strike="noStrike">
                 <a:solidFill>
                   <a:srgbClr val="F8FAFC"/>
                 </a:solidFill>
@@ -18748,7 +18685,7 @@
               </a:rPr>
               <a:t>Compatibilité Proton :</a:t>
             </a:r>
-            <a:endParaRPr/>
+            <a:endParaRPr sz="2000"/>
           </a:p>
           <a:p>
             <a:pPr indent="0" lvl="0" marL="0" marR="0" rtl="0" algn="l">
@@ -18761,7 +18698,7 @@
               <a:buNone/>
             </a:pPr>
             <a:r>
-              <a:rPr b="0" i="0" lang="en-US" sz="950" u="none" cap="none" strike="noStrike">
+              <a:rPr b="0" i="0" lang="en-US" sz="1550" u="none" cap="none" strike="noStrike">
                 <a:solidFill>
                   <a:srgbClr val="94A3B8"/>
                 </a:solidFill>
@@ -18772,7 +18709,7 @@
               </a:rPr>
               <a:t>Garantir le badge 'Deck Verified' dès le lancement (anti-triche compatible).</a:t>
             </a:r>
-            <a:endParaRPr/>
+            <a:endParaRPr sz="2000"/>
           </a:p>
           <a:p>
             <a:pPr indent="0" lvl="0" marL="0" marR="0" rtl="0" algn="l">
@@ -18785,7 +18722,7 @@
               <a:buNone/>
             </a:pPr>
             <a:r>
-              <a:rPr b="1" i="0" lang="en-US" sz="1000" u="none" cap="none" strike="noStrike">
+              <a:rPr b="1" i="0" lang="en-US" sz="1600" u="none" cap="none" strike="noStrike">
                 <a:solidFill>
                   <a:srgbClr val="F8FAFC"/>
                 </a:solidFill>
@@ -18796,7 +18733,7 @@
               </a:rPr>
               <a:t>Chinois Simplifié :</a:t>
             </a:r>
-            <a:endParaRPr/>
+            <a:endParaRPr sz="2000"/>
           </a:p>
           <a:p>
             <a:pPr indent="0" lvl="0" marL="0" marR="0" rtl="0" algn="l">
@@ -18809,7 +18746,7 @@
               <a:buNone/>
             </a:pPr>
             <a:r>
-              <a:rPr b="0" i="0" lang="en-US" sz="950" u="none" cap="none" strike="noStrike">
+              <a:rPr b="0" i="0" lang="en-US" sz="1550" u="none" cap="none" strike="noStrike">
                 <a:solidFill>
                   <a:srgbClr val="94A3B8"/>
                 </a:solidFill>
@@ -18820,7 +18757,7 @@
               </a:rPr>
               <a:t>24.5% du catalogue : bassin d'audience prioritaire hors Occident.</a:t>
             </a:r>
-            <a:endParaRPr/>
+            <a:endParaRPr sz="2000"/>
           </a:p>
         </p:txBody>
       </p:sp>
@@ -18833,6 +18770,285 @@
 </file>
 
 <file path=ppt/theme/theme1.xml><?xml version="1.0" encoding="utf-8"?>
+<a:theme xmlns:a="http://schemas.openxmlformats.org/drawingml/2006/main" xmlns:r="http://schemas.openxmlformats.org/officeDocument/2006/relationships" name="Office Theme">
+  <a:themeElements>
+    <a:clrScheme name="Office">
+      <a:dk1>
+        <a:srgbClr val="000000"/>
+      </a:dk1>
+      <a:lt1>
+        <a:srgbClr val="FFFFFF"/>
+      </a:lt1>
+      <a:dk2>
+        <a:srgbClr val="1F497D"/>
+      </a:dk2>
+      <a:lt2>
+        <a:srgbClr val="EEECE1"/>
+      </a:lt2>
+      <a:accent1>
+        <a:srgbClr val="4F81BD"/>
+      </a:accent1>
+      <a:accent2>
+        <a:srgbClr val="C0504D"/>
+      </a:accent2>
+      <a:accent3>
+        <a:srgbClr val="9BBB59"/>
+      </a:accent3>
+      <a:accent4>
+        <a:srgbClr val="8064A2"/>
+      </a:accent4>
+      <a:accent5>
+        <a:srgbClr val="4BACC6"/>
+      </a:accent5>
+      <a:accent6>
+        <a:srgbClr val="F79646"/>
+      </a:accent6>
+      <a:hlink>
+        <a:srgbClr val="0000FF"/>
+      </a:hlink>
+      <a:folHlink>
+        <a:srgbClr val="800080"/>
+      </a:folHlink>
+    </a:clrScheme>
+    <a:fontScheme name="Office">
+      <a:majorFont>
+        <a:latin typeface="Arial"/>
+        <a:ea typeface=""/>
+        <a:cs typeface=""/>
+        <a:font script="Jpan" typeface="ＭＳ Ｐゴシック"/>
+        <a:font script="Hang" typeface="맑은 고딕"/>
+        <a:font script="Hans" typeface="宋体"/>
+        <a:font script="Hant" typeface="新細明體"/>
+        <a:font script="Arab" typeface="Times New Roman"/>
+        <a:font script="Hebr" typeface="Times New Roman"/>
+        <a:font script="Thai" typeface="Angsana New"/>
+        <a:font script="Ethi" typeface="Nyala"/>
+        <a:font script="Beng" typeface="Vrinda"/>
+        <a:font script="Gujr" typeface="Shruti"/>
+        <a:font script="Khmr" typeface="MoolBoran"/>
+        <a:font script="Knda" typeface="Tunga"/>
+        <a:font script="Guru" typeface="Raavi"/>
+        <a:font script="Cans" typeface="Euphemia"/>
+        <a:font script="Cher" typeface="Plantagenet Cherokee"/>
+        <a:font script="Yiii" typeface="Microsoft Yi Baiti"/>
+        <a:font script="Tibt" typeface="Microsoft Himalaya"/>
+        <a:font script="Thaa" typeface="MV Boli"/>
+        <a:font script="Deva" typeface="Mangal"/>
+        <a:font script="Telu" typeface="Gautami"/>
+        <a:font script="Taml" typeface="Latha"/>
+        <a:font script="Syrc" typeface="Estrangelo Edessa"/>
+        <a:font script="Orya" typeface="Kalinga"/>
+        <a:font script="Mlym" typeface="Kartika"/>
+        <a:font script="Laoo" typeface="DokChampa"/>
+        <a:font script="Sinh" typeface="Iskoola Pota"/>
+        <a:font script="Mong" typeface="Mongolian Baiti"/>
+        <a:font script="Viet" typeface="Times New Roman"/>
+        <a:font script="Uigh" typeface="Microsoft Uighur"/>
+        <a:font script="Geor" typeface="Sylfaen"/>
+      </a:majorFont>
+      <a:minorFont>
+        <a:latin typeface="Arial"/>
+        <a:ea typeface=""/>
+        <a:cs typeface=""/>
+        <a:font script="Jpan" typeface="ＭＳ Ｐゴシック"/>
+        <a:font script="Hang" typeface="맑은 고딕"/>
+        <a:font script="Hans" typeface="宋体"/>
+        <a:font script="Hant" typeface="新細明體"/>
+        <a:font script="Arab" typeface="Arial"/>
+        <a:font script="Hebr" typeface="Arial"/>
+        <a:font script="Thai" typeface="Cordia New"/>
+        <a:font script="Ethi" typeface="Nyala"/>
+        <a:font script="Beng" typeface="Vrinda"/>
+        <a:font script="Gujr" typeface="Shruti"/>
+        <a:font script="Khmr" typeface="DaunPenh"/>
+        <a:font script="Knda" typeface="Tunga"/>
+        <a:font script="Guru" typeface="Raavi"/>
+        <a:font script="Cans" typeface="Euphemia"/>
+        <a:font script="Cher" typeface="Plantagenet Cherokee"/>
+        <a:font script="Yiii" typeface="Microsoft Yi Baiti"/>
+        <a:font script="Tibt" typeface="Microsoft Himalaya"/>
+        <a:font script="Thaa" typeface="MV Boli"/>
+        <a:font script="Deva" typeface="Mangal"/>
+        <a:font script="Telu" typeface="Gautami"/>
+        <a:font script="Taml" typeface="Latha"/>
+        <a:font script="Syrc" typeface="Estrangelo Edessa"/>
+        <a:font script="Orya" typeface="Kalinga"/>
+        <a:font script="Mlym" typeface="Kartika"/>
+        <a:font script="Laoo" typeface="DokChampa"/>
+        <a:font script="Sinh" typeface="Iskoola Pota"/>
+        <a:font script="Mong" typeface="Mongolian Baiti"/>
+        <a:font script="Viet" typeface="Arial"/>
+        <a:font script="Uigh" typeface="Microsoft Uighur"/>
+        <a:font script="Geor" typeface="Sylfaen"/>
+      </a:minorFont>
+    </a:fontScheme>
+    <a:fmtScheme name="Office">
+      <a:fillStyleLst>
+        <a:solidFill>
+          <a:schemeClr val="phClr"/>
+        </a:solidFill>
+        <a:gradFill rotWithShape="1">
+          <a:gsLst>
+            <a:gs pos="0">
+              <a:schemeClr val="phClr">
+                <a:tint val="50000"/>
+                <a:satMod val="300000"/>
+              </a:schemeClr>
+            </a:gs>
+            <a:gs pos="35000">
+              <a:schemeClr val="phClr">
+                <a:tint val="37000"/>
+                <a:satMod val="300000"/>
+              </a:schemeClr>
+            </a:gs>
+            <a:gs pos="100000">
+              <a:schemeClr val="phClr">
+                <a:tint val="15000"/>
+                <a:satMod val="350000"/>
+              </a:schemeClr>
+            </a:gs>
+          </a:gsLst>
+          <a:lin ang="16200000" scaled="1"/>
+        </a:gradFill>
+        <a:gradFill rotWithShape="1">
+          <a:gsLst>
+            <a:gs pos="0">
+              <a:schemeClr val="phClr">
+                <a:tint val="100000"/>
+                <a:shade val="100000"/>
+                <a:satMod val="130000"/>
+              </a:schemeClr>
+            </a:gs>
+            <a:gs pos="100000">
+              <a:schemeClr val="phClr">
+                <a:tint val="50000"/>
+                <a:shade val="100000"/>
+                <a:satMod val="350000"/>
+              </a:schemeClr>
+            </a:gs>
+          </a:gsLst>
+          <a:lin ang="16200000" scaled="0"/>
+        </a:gradFill>
+      </a:fillStyleLst>
+      <a:lnStyleLst>
+        <a:ln w="9525" cap="flat" cmpd="sng" algn="ctr">
+          <a:solidFill>
+            <a:schemeClr val="phClr">
+              <a:shade val="95000"/>
+              <a:satMod val="105000"/>
+            </a:schemeClr>
+          </a:solidFill>
+          <a:prstDash val="solid"/>
+        </a:ln>
+        <a:ln w="25400" cap="flat" cmpd="sng" algn="ctr">
+          <a:solidFill>
+            <a:schemeClr val="phClr"/>
+          </a:solidFill>
+          <a:prstDash val="solid"/>
+        </a:ln>
+        <a:ln w="38100" cap="flat" cmpd="sng" algn="ctr">
+          <a:solidFill>
+            <a:schemeClr val="phClr"/>
+          </a:solidFill>
+          <a:prstDash val="solid"/>
+        </a:ln>
+      </a:lnStyleLst>
+      <a:effectStyleLst>
+        <a:effectStyle>
+          <a:effectLst>
+            <a:outerShdw blurRad="40000" dist="20000" dir="5400000" rotWithShape="0">
+              <a:srgbClr val="000000">
+                <a:alpha val="38000"/>
+              </a:srgbClr>
+            </a:outerShdw>
+          </a:effectLst>
+        </a:effectStyle>
+        <a:effectStyle>
+          <a:effectLst>
+            <a:outerShdw blurRad="40000" dist="23000" dir="5400000" rotWithShape="0">
+              <a:srgbClr val="000000">
+                <a:alpha val="35000"/>
+              </a:srgbClr>
+            </a:outerShdw>
+          </a:effectLst>
+        </a:effectStyle>
+        <a:effectStyle>
+          <a:effectLst>
+            <a:outerShdw blurRad="40000" dist="23000" dir="5400000" rotWithShape="0">
+              <a:srgbClr val="000000">
+                <a:alpha val="35000"/>
+              </a:srgbClr>
+            </a:outerShdw>
+          </a:effectLst>
+          <a:scene3d>
+            <a:camera prst="orthographicFront">
+              <a:rot lat="0" lon="0" rev="0"/>
+            </a:camera>
+            <a:lightRig rig="threePt" dir="t">
+              <a:rot lat="0" lon="0" rev="1200000"/>
+            </a:lightRig>
+          </a:scene3d>
+          <a:sp3d>
+            <a:bevelT w="63500" h="25400"/>
+          </a:sp3d>
+        </a:effectStyle>
+      </a:effectStyleLst>
+      <a:bgFillStyleLst>
+        <a:solidFill>
+          <a:schemeClr val="phClr"/>
+        </a:solidFill>
+        <a:gradFill rotWithShape="1">
+          <a:gsLst>
+            <a:gs pos="0">
+              <a:schemeClr val="phClr">
+                <a:tint val="40000"/>
+                <a:satMod val="350000"/>
+              </a:schemeClr>
+            </a:gs>
+            <a:gs pos="40000">
+              <a:schemeClr val="phClr">
+                <a:tint val="45000"/>
+                <a:shade val="99000"/>
+                <a:satMod val="350000"/>
+              </a:schemeClr>
+            </a:gs>
+            <a:gs pos="100000">
+              <a:schemeClr val="phClr">
+                <a:shade val="20000"/>
+                <a:satMod val="255000"/>
+              </a:schemeClr>
+            </a:gs>
+          </a:gsLst>
+          <a:path path="circle">
+            <a:fillToRect l="50000" t="-80000" r="50000" b="180000"/>
+          </a:path>
+        </a:gradFill>
+        <a:gradFill rotWithShape="1">
+          <a:gsLst>
+            <a:gs pos="0">
+              <a:schemeClr val="phClr">
+                <a:tint val="80000"/>
+                <a:satMod val="300000"/>
+              </a:schemeClr>
+            </a:gs>
+            <a:gs pos="100000">
+              <a:schemeClr val="phClr">
+                <a:shade val="30000"/>
+                <a:satMod val="200000"/>
+              </a:schemeClr>
+            </a:gs>
+          </a:gsLst>
+          <a:path path="circle">
+            <a:fillToRect l="50000" t="50000" r="50000" b="50000"/>
+          </a:path>
+        </a:gradFill>
+      </a:bgFillStyleLst>
+    </a:fmtScheme>
+  </a:themeElements>
+</a:theme>
+</file>
+
+<file path=ppt/theme/theme2.xml><?xml version="1.0" encoding="utf-8"?>
 <a:theme xmlns:a="http://schemas.openxmlformats.org/drawingml/2006/main" xmlns:r="http://schemas.openxmlformats.org/officeDocument/2006/relationships">
   <a:themeElements>
     <a:clrScheme name="Default">
@@ -19109,283 +19325,4 @@
     </a:fmtScheme>
   </a:themeElements>
 </a:theme>
-</file>
-
-<file path=ppt/theme/theme2.xml><?xml version="1.0" encoding="utf-8"?>
-<a:theme xmlns:a="http://schemas.openxmlformats.org/drawingml/2006/main" xmlns:r="http://schemas.openxmlformats.org/officeDocument/2006/relationships" name="Office Theme">
-  <a:themeElements>
-    <a:clrScheme name="Office">
-      <a:dk1>
-        <a:srgbClr val="000000"/>
-      </a:dk1>
-      <a:lt1>
-        <a:srgbClr val="FFFFFF"/>
-      </a:lt1>
-      <a:dk2>
-        <a:srgbClr val="1F497D"/>
-      </a:dk2>
-      <a:lt2>
-        <a:srgbClr val="EEECE1"/>
-      </a:lt2>
-      <a:accent1>
-        <a:srgbClr val="4F81BD"/>
-      </a:accent1>
-      <a:accent2>
-        <a:srgbClr val="C0504D"/>
-      </a:accent2>
-      <a:accent3>
-        <a:srgbClr val="9BBB59"/>
-      </a:accent3>
-      <a:accent4>
-        <a:srgbClr val="8064A2"/>
-      </a:accent4>
-      <a:accent5>
-        <a:srgbClr val="4BACC6"/>
-      </a:accent5>
-      <a:accent6>
-        <a:srgbClr val="F79646"/>
-      </a:accent6>
-      <a:hlink>
-        <a:srgbClr val="0000FF"/>
-      </a:hlink>
-      <a:folHlink>
-        <a:srgbClr val="800080"/>
-      </a:folHlink>
-    </a:clrScheme>
-    <a:fontScheme name="Office">
-      <a:majorFont>
-        <a:latin typeface="Arial"/>
-        <a:ea typeface=""/>
-        <a:cs typeface=""/>
-        <a:font script="Jpan" typeface="ＭＳ Ｐゴシック"/>
-        <a:font script="Hang" typeface="맑은 고딕"/>
-        <a:font script="Hans" typeface="宋体"/>
-        <a:font script="Hant" typeface="新細明體"/>
-        <a:font script="Arab" typeface="Times New Roman"/>
-        <a:font script="Hebr" typeface="Times New Roman"/>
-        <a:font script="Thai" typeface="Angsana New"/>
-        <a:font script="Ethi" typeface="Nyala"/>
-        <a:font script="Beng" typeface="Vrinda"/>
-        <a:font script="Gujr" typeface="Shruti"/>
-        <a:font script="Khmr" typeface="MoolBoran"/>
-        <a:font script="Knda" typeface="Tunga"/>
-        <a:font script="Guru" typeface="Raavi"/>
-        <a:font script="Cans" typeface="Euphemia"/>
-        <a:font script="Cher" typeface="Plantagenet Cherokee"/>
-        <a:font script="Yiii" typeface="Microsoft Yi Baiti"/>
-        <a:font script="Tibt" typeface="Microsoft Himalaya"/>
-        <a:font script="Thaa" typeface="MV Boli"/>
-        <a:font script="Deva" typeface="Mangal"/>
-        <a:font script="Telu" typeface="Gautami"/>
-        <a:font script="Taml" typeface="Latha"/>
-        <a:font script="Syrc" typeface="Estrangelo Edessa"/>
-        <a:font script="Orya" typeface="Kalinga"/>
-        <a:font script="Mlym" typeface="Kartika"/>
-        <a:font script="Laoo" typeface="DokChampa"/>
-        <a:font script="Sinh" typeface="Iskoola Pota"/>
-        <a:font script="Mong" typeface="Mongolian Baiti"/>
-        <a:font script="Viet" typeface="Times New Roman"/>
-        <a:font script="Uigh" typeface="Microsoft Uighur"/>
-        <a:font script="Geor" typeface="Sylfaen"/>
-      </a:majorFont>
-      <a:minorFont>
-        <a:latin typeface="Arial"/>
-        <a:ea typeface=""/>
-        <a:cs typeface=""/>
-        <a:font script="Jpan" typeface="ＭＳ Ｐゴシック"/>
-        <a:font script="Hang" typeface="맑은 고딕"/>
-        <a:font script="Hans" typeface="宋体"/>
-        <a:font script="Hant" typeface="新細明體"/>
-        <a:font script="Arab" typeface="Arial"/>
-        <a:font script="Hebr" typeface="Arial"/>
-        <a:font script="Thai" typeface="Cordia New"/>
-        <a:font script="Ethi" typeface="Nyala"/>
-        <a:font script="Beng" typeface="Vrinda"/>
-        <a:font script="Gujr" typeface="Shruti"/>
-        <a:font script="Khmr" typeface="DaunPenh"/>
-        <a:font script="Knda" typeface="Tunga"/>
-        <a:font script="Guru" typeface="Raavi"/>
-        <a:font script="Cans" typeface="Euphemia"/>
-        <a:font script="Cher" typeface="Plantagenet Cherokee"/>
-        <a:font script="Yiii" typeface="Microsoft Yi Baiti"/>
-        <a:font script="Tibt" typeface="Microsoft Himalaya"/>
-        <a:font script="Thaa" typeface="MV Boli"/>
-        <a:font script="Deva" typeface="Mangal"/>
-        <a:font script="Telu" typeface="Gautami"/>
-        <a:font script="Taml" typeface="Latha"/>
-        <a:font script="Syrc" typeface="Estrangelo Edessa"/>
-        <a:font script="Orya" typeface="Kalinga"/>
-        <a:font script="Mlym" typeface="Kartika"/>
-        <a:font script="Laoo" typeface="DokChampa"/>
-        <a:font script="Sinh" typeface="Iskoola Pota"/>
-        <a:font script="Mong" typeface="Mongolian Baiti"/>
-        <a:font script="Viet" typeface="Arial"/>
-        <a:font script="Uigh" typeface="Microsoft Uighur"/>
-        <a:font script="Geor" typeface="Sylfaen"/>
-      </a:minorFont>
-    </a:fontScheme>
-    <a:fmtScheme name="Office">
-      <a:fillStyleLst>
-        <a:solidFill>
-          <a:schemeClr val="phClr"/>
-        </a:solidFill>
-        <a:gradFill rotWithShape="1">
-          <a:gsLst>
-            <a:gs pos="0">
-              <a:schemeClr val="phClr">
-                <a:tint val="50000"/>
-                <a:satMod val="300000"/>
-              </a:schemeClr>
-            </a:gs>
-            <a:gs pos="35000">
-              <a:schemeClr val="phClr">
-                <a:tint val="37000"/>
-                <a:satMod val="300000"/>
-              </a:schemeClr>
-            </a:gs>
-            <a:gs pos="100000">
-              <a:schemeClr val="phClr">
-                <a:tint val="15000"/>
-                <a:satMod val="350000"/>
-              </a:schemeClr>
-            </a:gs>
-          </a:gsLst>
-          <a:lin ang="16200000" scaled="1"/>
-        </a:gradFill>
-        <a:gradFill rotWithShape="1">
-          <a:gsLst>
-            <a:gs pos="0">
-              <a:schemeClr val="phClr">
-                <a:tint val="100000"/>
-                <a:shade val="100000"/>
-                <a:satMod val="130000"/>
-              </a:schemeClr>
-            </a:gs>
-            <a:gs pos="100000">
-              <a:schemeClr val="phClr">
-                <a:tint val="50000"/>
-                <a:shade val="100000"/>
-                <a:satMod val="350000"/>
-              </a:schemeClr>
-            </a:gs>
-          </a:gsLst>
-          <a:lin ang="16200000" scaled="0"/>
-        </a:gradFill>
-      </a:fillStyleLst>
-      <a:lnStyleLst>
-        <a:ln w="9525" cap="flat" cmpd="sng" algn="ctr">
-          <a:solidFill>
-            <a:schemeClr val="phClr">
-              <a:shade val="95000"/>
-              <a:satMod val="105000"/>
-            </a:schemeClr>
-          </a:solidFill>
-          <a:prstDash val="solid"/>
-        </a:ln>
-        <a:ln w="25400" cap="flat" cmpd="sng" algn="ctr">
-          <a:solidFill>
-            <a:schemeClr val="phClr"/>
-          </a:solidFill>
-          <a:prstDash val="solid"/>
-        </a:ln>
-        <a:ln w="38100" cap="flat" cmpd="sng" algn="ctr">
-          <a:solidFill>
-            <a:schemeClr val="phClr"/>
-          </a:solidFill>
-          <a:prstDash val="solid"/>
-        </a:ln>
-      </a:lnStyleLst>
-      <a:effectStyleLst>
-        <a:effectStyle>
-          <a:effectLst>
-            <a:outerShdw blurRad="40000" dist="20000" dir="5400000" rotWithShape="0">
-              <a:srgbClr val="000000">
-                <a:alpha val="38000"/>
-              </a:srgbClr>
-            </a:outerShdw>
-          </a:effectLst>
-        </a:effectStyle>
-        <a:effectStyle>
-          <a:effectLst>
-            <a:outerShdw blurRad="40000" dist="23000" dir="5400000" rotWithShape="0">
-              <a:srgbClr val="000000">
-                <a:alpha val="35000"/>
-              </a:srgbClr>
-            </a:outerShdw>
-          </a:effectLst>
-        </a:effectStyle>
-        <a:effectStyle>
-          <a:effectLst>
-            <a:outerShdw blurRad="40000" dist="23000" dir="5400000" rotWithShape="0">
-              <a:srgbClr val="000000">
-                <a:alpha val="35000"/>
-              </a:srgbClr>
-            </a:outerShdw>
-          </a:effectLst>
-          <a:scene3d>
-            <a:camera prst="orthographicFront">
-              <a:rot lat="0" lon="0" rev="0"/>
-            </a:camera>
-            <a:lightRig rig="threePt" dir="t">
-              <a:rot lat="0" lon="0" rev="1200000"/>
-            </a:lightRig>
-          </a:scene3d>
-          <a:sp3d>
-            <a:bevelT w="63500" h="25400"/>
-          </a:sp3d>
-        </a:effectStyle>
-      </a:effectStyleLst>
-      <a:bgFillStyleLst>
-        <a:solidFill>
-          <a:schemeClr val="phClr"/>
-        </a:solidFill>
-        <a:gradFill rotWithShape="1">
-          <a:gsLst>
-            <a:gs pos="0">
-              <a:schemeClr val="phClr">
-                <a:tint val="40000"/>
-                <a:satMod val="350000"/>
-              </a:schemeClr>
-            </a:gs>
-            <a:gs pos="40000">
-              <a:schemeClr val="phClr">
-                <a:tint val="45000"/>
-                <a:shade val="99000"/>
-                <a:satMod val="350000"/>
-              </a:schemeClr>
-            </a:gs>
-            <a:gs pos="100000">
-              <a:schemeClr val="phClr">
-                <a:shade val="20000"/>
-                <a:satMod val="255000"/>
-              </a:schemeClr>
-            </a:gs>
-          </a:gsLst>
-          <a:path path="circle">
-            <a:fillToRect l="50000" t="-80000" r="50000" b="180000"/>
-          </a:path>
-        </a:gradFill>
-        <a:gradFill rotWithShape="1">
-          <a:gsLst>
-            <a:gs pos="0">
-              <a:schemeClr val="phClr">
-                <a:tint val="80000"/>
-                <a:satMod val="300000"/>
-              </a:schemeClr>
-            </a:gs>
-            <a:gs pos="100000">
-              <a:schemeClr val="phClr">
-                <a:shade val="30000"/>
-                <a:satMod val="200000"/>
-              </a:schemeClr>
-            </a:gs>
-          </a:gsLst>
-          <a:path path="circle">
-            <a:fillToRect l="50000" t="50000" r="50000" b="50000"/>
-          </a:path>
-        </a:gradFill>
-      </a:bgFillStyleLst>
-    </a:fmtScheme>
-  </a:themeElements>
-</a:theme>
 </file>
</xml_diff>